<commit_message>
WIP(lectures): update lecture 02 PPTX and add speaker notes v3
- Update AI대체불가Skills v7 PPTX with latest slide changes
- Add notes-v3.json with full speaker script for 12 slides
- Cover AI disruption context, judgment economy framework, and 3 skills
- Include 60-second intro rewrite example and weekly homework prompt
</commit_message>
<xml_diff>
--- a/lectures/02_ai_skills/AI대체불가Skills_v7.pptx
+++ b/lectures/02_ai_skills/AI대체불가Skills_v7.pptx
@@ -512,7 +512,7 @@
           <a:p>
             <a:r>
               <a:rPr lang="en-US" dirty="0"/>
-              <a:t>(강의 시작 전 타이틀 슬라이드. 청중이 착석하면서 볼 수 있도록 미리 띄워놓기.)</a:t>
+              <a:t>(타이틀 슬라이드. 청중이 착석하면서 볼 수 있도록 미리 띄워놓기.)</a:t>
             </a:r>
             <a:endParaRPr lang="en-US" dirty="0"/>
           </a:p>
@@ -600,7 +600,13 @@
           <a:p>
             <a:r>
               <a:rPr lang="en-US" dirty="0"/>
-              <a:t>오늘 이 강의가 끝나고 딱 한 가지만 해주십시오. 핸드폰을 꺼내서, 최근 3개월간 연락하지 못한 사람 한 명에게 메시지를 보내세요. 거창할 필요 없습니다. '요즘 어떻게 지내세요? 한번 뵙고 싶습니다.' 이 한 줄이면 됩니다.</a:t>
+              <a:t>이 세 가지를 알면, 우리가 매주 하는 60초 소개가 완전히 달라집니다.
+솔직히 말씀드리면 — 우리가 평소에 하는 60초 소개, ChatGPT한테 시키면 비슷하게 나옵니다.
+"저는 인테리어 업체를 운영하고 있습니다. 주거, 상업 공간 다 합니다. 리모델링 필요하신 분 있으면 소개 부탁드립니다."
+이거, AI가 5초 만에 쓰는 수준입니다. 이 소개를 듣고 소개해줄 사람이 떠오르시나요? 안 떠오르죠.
+그런데 내 Skill이 뭔지 아는 분은 이렇게 말합니다.
+"저는 강남에서 15년째 인테리어를 하고 있습니다. 제가 잘하는 건 예쁜 시공이 아니라, 도면 보고 3분 안에 '여기 건드리면 큰일 납니다'를 찾아내는 겁니다. 2호점 내시는 프랜차이즈 사장님 계시면 소개해주세요. 첫 미팅에서 도면 보고 리스크 3개는 바로 짚어드립니다."
+이 사람은 자기 Skill을 정확히 압니다. 맥락을 읽고, 리스크를 짚어주고, "이건 하지 마세요"를 말할 수 있는 사람. 그래서 소개하고 싶은 사람의 얼굴이 떠오르는 겁니다.</a:t>
             </a:r>
             <a:endParaRPr lang="en-US" dirty="0"/>
           </a:p>
@@ -688,7 +694,17 @@
           <a:p>
             <a:r>
               <a:rPr lang="en-US" dirty="0"/>
-              <a:t>(느리게, 무게 있게) AI시대에 가장 비싼 것은 신뢰입니다. 그리고 이 방에 있는 여러분이, 신뢰를 만드는 사람들입니다. 감사합니다.</a:t>
+              <a:t>정리하겠습니다.
+지난 시간에 신뢰가 중요하다고 했습니다. 오늘은 그 신뢰 안에 담을 것을 찾았습니다.
+내가 읽는 맥락, 내가 감수하는 리스크, 내가 버리는 것들.
+이 세 가지가 AI가 대체할 수 없는 나만의 Skills입니다. 여러분이 10년, 20년 사업하면서 복리로 쌓아온 자산이에요. AI가 하루아침에 따라올 수 없습니다.
+이번 주 숙제 드리겠습니다.
+다음 주 60초 소개 준비할 때, 이 질문에 먼저 답해보세요.
+"내 사업에서 내가 내리는 판단 중, AI가 절대 못 하는 한 가지는?"
+맥락을 읽는 건지, 리스크를 감수하는 건지, 버리는 판단을 하는 건지.
+그 답이 나오면, 60초 소개의 첫 문장이 됩니다. "저는 ___를 하는 사람이 아니라, ___를 판단하는 사람입니다."
+다음 주에 바뀐 소개로 한번 해보시고, 반응이 어떻게 달라지는지 알려주세요.
+감사합니다.</a:t>
             </a:r>
             <a:endParaRPr lang="en-US" dirty="0"/>
           </a:p>
@@ -776,7 +792,14 @@
           <a:p>
             <a:r>
               <a:rPr lang="en-US" dirty="0"/>
-              <a:t>여러분, 오픈클로 들어보셨죠? 한 달 만에 GitHub 스타 20만 개를 찍은 AI 에이전트입니다. 카카오, 네이버, 당근마켓이 보안 문제로 사내 사용을 금지시켰을 정도로 임팩트가 큰 도구입니다. 카톡으로 메시지 하나 보내면, AI가 알아서 컴퓨터를 조작합니다. PPT 만들고, 이메일 보내고, 견적서까지 작성합니다. 사람이 없어도요.</a:t>
+              <a:t>여러분, 솔직히 하나 여쭤볼게요.
+지난 한 달 안에, "이거 AI한테 시키면 되겠다" 하고 직원한테 줄 일을 안 준 적 있으신 분?
+... (손 드는 사람 확인)
+그러면 여러분의 고객도, 여러분한테 똑같은 생각을 하고 있을 수 있습니다.
+(PAUSE)
+지난 시간에 AI 시대에 결국 남는 건 신뢰라는 이야기 했습니다. 오늘은 그 다음 질문입니다.
+그 신뢰를, 뭘로 채울 건가?
+"저 믿으세요"만으로는 안 됩니다. 고객이 나를 믿어야 할 구체적인 이유 — 그걸 말로 할 수 있어야 합니다. 오늘 그걸 찾는 시간입니다.</a:t>
             </a:r>
             <a:endParaRPr lang="en-US" dirty="0"/>
           </a:p>
@@ -864,7 +887,10 @@
           <a:p>
             <a:r>
               <a:rPr lang="en-US" dirty="0"/>
-              <a:t>(2초 침묵 후, 천천히) 그런데 이 AI가 못하는 게 딱 하나 있습니다. (슬라이드 전환) 신뢰. '이 사람을 믿겠다'는 결정은 누가 내립니까? AI가요? 아닙니다. 여전히 사람입니다. 오늘 저는 이 한 가지 이야기를 하려고 합니다.</a:t>
+              <a:t>지금 AI가 어디까지 와있는지 한번 보겠습니다.
+요즘 AI 중에 Claude라는 게 있는데요, ChatGPT랑 비슷한 건데 — 올해 "Skills"라는 기능을 냈어요. 뭐냐면, AI한테 우리 회사 업무 방식을 가르치는 겁니다. 한번 가르쳐놓으면, 이메일, 제안서, PPT를 우리 회사 스타일로 알아서 만들어요.
+예전에는 "AI가 글을 잘 쓴다" 수준이었는데, 지금은 "3년차 직원처럼 알아서 일한다" 수준까지 온 겁니다.
+특별한 기술 없어도 됩니다. 누구나 쓸 수 있어요. 여러분 경쟁사도 이미 쓰고 있을 겁니다.</a:t>
             </a:r>
             <a:endParaRPr lang="en-US" dirty="0"/>
           </a:p>
@@ -952,7 +978,12 @@
           <a:p>
             <a:r>
               <a:rPr lang="en-US" dirty="0"/>
-              <a:t>자, 이제 숫자로 보겠습니다. AI가 모든 것을 싸고 빠르게 만드는 시대에, 유일하게 값이 올라가고 있는 것이 있습니다.</a:t>
+              <a:t>하버드 비즈니스 리뷰가 올해 충격적인 기사를 냈습니다. 핵심이 뭐냐면 — 기업들이 AI가 잘해서 사람을 자르는 게 아니라, 잘할 것 같아서 자르고 있다는 겁니다. 아직 완벽하지도 않은데, 가능성만 보고 줄이고 있어요.
+여기까지가 현실입니다. 그런데 여기서 끝나면 오늘 교육이 아니라 공포 영화죠.
+(PAUSE)
+솔직히 말씀드리면, 저도 이 주제를 준비하면서 좀 무서웠습니다. AI한테 "BNI 10분 교육 대본 써줘"라고 했더니 진짜 나오거든요. 그것도 꽤 괜찮게.
+그래서 생각했습니다 — 그러면 내가 여기 서 있는 이유가 뭐지?
+그 답을 찾는 과정에서 오늘 이야기가 나왔습니다.</a:t>
             </a:r>
             <a:endParaRPr lang="en-US" dirty="0"/>
           </a:p>
@@ -1040,7 +1071,15 @@
           <a:p>
             <a:r>
               <a:rPr lang="en-US" dirty="0"/>
-              <a:t>숫자를 보겠습니다. 전문가의 64%가 AI가 만들어낸 분석보다 자신의 인간 네트워크에서 얻은 인사이트를 더 신뢰한다고 응답했습니다. 영업에서도 마찬가지입니다. 관계 기반 추천의 전환율은 15~25%인데, 콜드콜은 고작 2~3%입니다. 4배 차이. 지인의 추천을 신뢰하는 비율은 92%인데, 온라인 광고는 33%에 불과합니다. AI가 정보를 무료로 만들수록, '누가 말했느냐'의 가치, 즉 신뢰의 가격은 올라가고 있습니다.</a:t>
+              <a:t>전세계 기업들이 쓰는 Notion이라는 업무 협업 도구가 있는데요, 이 회사가 재밌는 걸 발견했습니다.
+Notion이 파트너 컨설턴트 프로그램을 운영하거든요. 그런데 데이터를 보니까 — 컨설턴트가 들어간 회사의 매출이 거의 2배로 뛴다는 겁니다.
+AI 도구는 그 회사에도 이미 있었어요. 같은 도구를 쓰고 있었는데, 사람이 들어가서 세팅을 해주니까 결과가 완전히 달라진 거예요.
+Notion은 이걸 "판단력의 경제" 시대라고 부릅니다.
+AI가 나오면서 기술 차이가 거의 없어졌어요. 누구나 예쁜 제안서 만들 수 있고, 누구나 데이터 분석할 수 있어요. (숨) 그런데 — 그 AI를 어디에 쓸지, 지금 이걸 해야 하는지 말아야 하는지. 이 판단은 아직 사람만 할 수 있습니다.
+그리고 Notion은 이렇게 말합니다 — "판단력은 복리로 쌓인다."
+여러분이 10년, 20년 사업하면서 쌓아온 것들. AI는 그걸 하루아침에 복사할 수 없습니다.
+좋습니다, 판단력이 중요하다 — 여기까진 알겠는데요. 내 판단력이 구체적으로 뭔지 모르면 써먹을 수가 없습니다. 고객한테 말할 수도 없고, 여기서 레퍼럴 요청할 때도 쓸 수가 없어요.
+AI가 따라올 수 없는 판단력, 세 가지 유형으로 정리해봤습니다. 이 중에 내가 어디에 해당하는지 들으면서 생각해보세요.</a:t>
             </a:r>
             <a:endParaRPr lang="en-US" dirty="0"/>
           </a:p>
@@ -1128,7 +1167,7 @@
           <a:p>
             <a:r>
               <a:rPr lang="en-US" dirty="0"/>
-              <a:t>링크드인이 3,000명 이상을 대상으로 조사한 결과, 일자리의 85%가 네트워킹을 통해 채워집니다. 추천 지원자는 전체의 7%에 불과하지만, 실제 채용의 40%를 차지합니다. 더 아이러니한 건, AI 채용 필터가 강화될수록 이 수치가 더 올라간다는 겁니다.</a:t>
+              <a:t>(전환 슬라이드 — 세 가지 판단력 프레임워크 소개. 잠시 멈추고 청중이 읽도록 기다린다.)</a:t>
             </a:r>
             <a:endParaRPr lang="en-US" dirty="0"/>
           </a:p>
@@ -1216,7 +1255,11 @@
           <a:p>
             <a:r>
               <a:rPr lang="en-US" dirty="0"/>
-              <a:t>여러분이 매주 하고 계신 그 추천 한 건. 그게 뭔지 다시 생각해보겠습니다. BNI 회원들이 지난 12개월간 추천을 통해 만들어낸 수익이 약 35조원입니다. 1,740만 건의 추천이 오갔습니다. 추천 한 건의 의미는, 내 평판을 걸고 누군가를 보증한다는 뜻입니다. 이것은 어떤 AI 알고리즘도 생성할 수 없는, 인간 고유의 행위입니다.</a:t>
+              <a:t>세무사 사무실을 운영하시는 분이 계시다면 — 지금 AI가 장부 정리, 세금 계산은 다 합니다. 삼쩜삼 같은 앱이 5만원에 해줘요.
+그런데요. 그 거래처 사장님이 "올해 좀 힘들어요"라고 했을 때, 그게 진짜 힘든 건지, 세금 좀 줄여달라는 건지, 아니면 사업 정리를 고민하는 건지 — 그 뉘앙스를 읽는 건 AI가 못 합니다.
+왜냐면 AI한테는 그 사장님이랑 소주 마시면서 들은 이야기가 없으니까요.
+이게 맥락입니다. 숫자 뒤에 있는 진짜 상황을 읽는 능력.
+여러분 사업에서, 고객이 말 안 해도 여러분이 알아채는 것들이 있잖아요. 그게 여러분의 첫 번째 Skill입니다.</a:t>
             </a:r>
             <a:endParaRPr lang="en-US" dirty="0"/>
           </a:p>
@@ -1304,7 +1347,12 @@
           <a:p>
             <a:r>
               <a:rPr lang="en-US" dirty="0"/>
-              <a:t>자, 그러면 우리가 오늘부터 할 수 있는 것은 무엇인가.</a:t>
+              <a:t>AI는 데이터 보고 가장 안전한 답을 내놓습니다. 그런데 사업에는 데이터에 없는 판단이 필요한 순간이 있어요.
+제조업 하시는 분 중에 이런 경험 있으실 겁니다. (숨) 원자재 가격이 오르고 있어요. 시스템은 "발주 중단"을 추천합니다. (숨) 근데 여러분은 이렇게 판단하는 거죠. "아니, 지금 오히려 밀어야 해. 저 사장은 어려울 때 도와주면 나중에 갚는 사람이야."
+틀릴 수도 있습니다. 그런데 이 판단을 내리는 건 사람만 할 수 있어요.
+왜냐면 AI는 추천은 하지만 책임지지 않습니다. 새벽 2시에 문제 생겼을 때 전화 받는 건 여러분이에요.
+(PAUSE)
+여러분이 사업에서 베팅한 순간들, 틀릴 줄 알면서도 밀어붙인 순간들. 그게 두 번째 Skill입니다.</a:t>
             </a:r>
             <a:endParaRPr lang="en-US" dirty="0"/>
           </a:p>
@@ -1392,7 +1440,12 @@
           <a:p>
             <a:r>
               <a:rPr lang="en-US" dirty="0"/>
-              <a:t>AI에게 시간을 뺏기는 것이 아니라, AI가 절약해준 시간을 사람에게 투자하세요. 1-1-1 네트워킹 법칙입니다. 매주 1명에게 먼저 연락하세요. 매주 1시간을 만남에 투자하세요. 만남마다 상대에게 1가지 도움을 먼저 제공하세요. 1년이면 52명, 3년이면 150명입니다. 던바의 수, 즉 의미 있는 관계를 유지할 수 있는 상한이 150명입니다. 3년이면 당신의 관계 자본이 가득 찹니다.</a:t>
+              <a:t>이게 사실 가장 어려운 겁니다.
+AI는 만드는 건 미친 듯이 잘합니다. 시키면 10개든 100개든 나와요. 문제는 다 괜찮다는 겁니다. 다 괜찮은데 뭘 쓸 건지 — 이걸 고르는 게 판단입니다. 그리고 더 어려운 건, 9개를 버리는 판단입니다.
+보험 설계사 하시는 분이면 아실 거예요. 고객이 "이 특약 넣어주세요" 하는데, 그걸 넣으면 3년 뒤에 그 고객이 오히려 손해 보는 경우가 있잖아요.
+AI는 고객이 원하는 대로 설계서를 만들어줍니다. 하지만 "사장님, 이건 안 하시는 게 맞습니다"라고 말하는 건 AI가 못 합니다.
+"안 한다"고 말할 수 있는 것. 그게 여러분이 받는 수수료의 진짜 근거입니다.
+고객한테 "이건 하지 마세요"라고 말해본 적 있으시죠? 그게 세 번째 Skill입니다.</a:t>
             </a:r>
             <a:endParaRPr lang="en-US" dirty="0"/>
           </a:p>
@@ -6120,7 +6173,7 @@
         <p:spPr>
           <a:xfrm>
             <a:off x="558701" y="558701"/>
-            <a:ext cx="812453" cy="250627"/>
+            <a:ext cx="848469" cy="241102"/>
           </a:xfrm>
           <a:prstGeom prst="rect">
             <a:avLst/>
@@ -6150,7 +6203,7 @@
         <p:spPr>
           <a:xfrm>
             <a:off x="736402" y="622102"/>
-            <a:ext cx="484474" cy="123825"/>
+            <a:ext cx="522652" cy="114300"/>
           </a:xfrm>
           <a:prstGeom prst="rect">
             <a:avLst/>
@@ -6188,7 +6241,7 @@
         </p:nvSpPr>
         <p:spPr>
           <a:xfrm>
-            <a:off x="558701" y="936278"/>
+            <a:off x="558701" y="926753"/>
             <a:ext cx="8508194" cy="396180"/>
           </a:xfrm>
           <a:prstGeom prst="rect">
@@ -6233,7 +6286,7 @@
         </p:nvSpPr>
         <p:spPr>
           <a:xfrm>
-            <a:off x="558701" y="1637258"/>
+            <a:off x="558701" y="1627733"/>
             <a:ext cx="8026598" cy="888802"/>
           </a:xfrm>
           <a:prstGeom prst="rect">
@@ -6263,7 +6316,7 @@
         </p:nvSpPr>
         <p:spPr>
           <a:xfrm>
-            <a:off x="914251" y="1891159"/>
+            <a:off x="914251" y="1881634"/>
             <a:ext cx="7754428" cy="381000"/>
           </a:xfrm>
           <a:prstGeom prst="rect">
@@ -6306,7 +6359,7 @@
         <p:spPr>
           <a:xfrm>
             <a:off x="558701" y="4006007"/>
-            <a:ext cx="2722584" cy="314771"/>
+            <a:ext cx="2714854" cy="314771"/>
           </a:xfrm>
           <a:prstGeom prst="rect">
             <a:avLst/>
@@ -6348,7 +6401,7 @@
         <p:spPr>
           <a:xfrm>
             <a:off x="558701" y="4320778"/>
-            <a:ext cx="2722584" cy="314771"/>
+            <a:ext cx="2714854" cy="314771"/>
           </a:xfrm>
           <a:prstGeom prst="rect">
             <a:avLst/>

</xml_diff>